<commit_message>
Complete ResNet18 architecture ablation
</commit_message>
<xml_diff>
--- a/presentation/CORES_MDE_presentation.pptx
+++ b/presentation/CORES_MDE_presentation.pptx
@@ -17,6 +17,7 @@
     <p:sldId id="265" r:id="rId16"/>
     <p:sldId id="266" r:id="rId17"/>
     <p:sldId id="267" r:id="rId18"/>
+    <p:sldId id="268" r:id="rId19"/>
   </p:sldIdLst>
   <p:sldSz cx="12191695" cy="6858000" type="screen4x3"/>
   <p:notesSz cx="6858000" cy="9144000"/>
@@ -3440,7 +3441,7 @@
               </a:defRPr>
             </a:pPr>
             <a:r>
-              <a:t>Failure cases and limitations</a:t>
+              <a:t>Architecture ablation: ResNet18</a:t>
             </a:r>
           </a:p>
         </p:txBody>
@@ -3454,7 +3455,7 @@
         <p:spPr>
           <a:xfrm>
             <a:off x="731520" y="1234440"/>
-            <a:ext cx="10515600" cy="5029200"/>
+            <a:ext cx="4892040" cy="5029200"/>
           </a:xfrm>
           <a:prstGeom prst="rect">
             <a:avLst/>
@@ -3478,7 +3479,7 @@
               </a:defRPr>
             </a:pPr>
             <a:r>
-              <a:t>NYU indoor versus KITTI roads is a broad, visually easy domain shift.</a:t>
+              <a:t>ResNet18: 11.38M parameters versus MobileNetV2's 2.39M.</a:t>
             </a:r>
           </a:p>
           <a:p>
@@ -3493,7 +3494,7 @@
               </a:defRPr>
             </a:pPr>
             <a:r>
-              <a:t>The NYU model is capped at 10 m, so KITTI metric depth deteriorates sharply.</a:t>
+              <a:t>NYU-test delta1 improves from 0.7181 to 0.7652.</a:t>
             </a:r>
           </a:p>
           <a:p>
@@ -3508,7 +3509,7 @@
               </a:defRPr>
             </a:pPr>
             <a:r>
-              <a:t>Gaussian near-OOD corruption: AUROC 0.94273, FPR95 0.388.</a:t>
+              <a:t>Middle-magnitude CORES falls from 0.999943 / 0.000 to 0.834523 / 0.499.</a:t>
             </a:r>
           </a:p>
           <a:p>
@@ -3523,7 +3524,7 @@
               </a:defRPr>
             </a:pPr>
             <a:r>
-              <a:t>One trained architecture and one checkpoint.</a:t>
+              <a:t>ImageNet-only ResNet18 is stronger than its depth-trained version.</a:t>
             </a:r>
           </a:p>
           <a:p>
@@ -3538,29 +3539,38 @@
               </a:defRPr>
             </a:pPr>
             <a:r>
-              <a:t>FastDepth-style MobileNetV2, not an exact MobileNetV1 reproduction.</a:t>
-            </a:r>
-          </a:p>
-          <a:p>
-            <a:pPr>
-              <a:spcAft>
-                <a:spcPts val="1400"/>
-              </a:spcAft>
-              <a:defRPr sz="2000">
-                <a:solidFill>
-                  <a:srgbClr val="232323"/>
-                </a:solidFill>
-              </a:defRPr>
-            </a:pPr>
-            <a:r>
-              <a:t>Dense-prediction channel selection is an explicit adaptation of CORES.</a:t>
-            </a:r>
-          </a:p>
-        </p:txBody>
-      </p:sp>
-      <p:sp>
-        <p:nvSpPr>
-          <p:cNvPr id="4" name="TextBox 3"/>
+              <a:t>Depth quality does not predict OOD quality; the response signal is architecture-dependent.</a:t>
+            </a:r>
+          </a:p>
+        </p:txBody>
+      </p:sp>
+      <p:pic>
+        <p:nvPicPr>
+          <p:cNvPr id="4" name="Picture 3" descr="09_architecture_comparison.png"/>
+          <p:cNvPicPr>
+            <a:picLocks noChangeAspect="1"/>
+          </p:cNvPicPr>
+          <p:nvPr/>
+        </p:nvPicPr>
+        <p:blipFill>
+          <a:blip r:embed="rId2"/>
+          <a:stretch>
+            <a:fillRect/>
+          </a:stretch>
+        </p:blipFill>
+        <p:spPr>
+          <a:xfrm>
+            <a:off x="5760720" y="1143000"/>
+            <a:ext cx="5943600" cy="1876562"/>
+          </a:xfrm>
+          <a:prstGeom prst="rect">
+            <a:avLst/>
+          </a:prstGeom>
+        </p:spPr>
+      </p:pic>
+      <p:sp>
+        <p:nvSpPr>
+          <p:cNvPr id="5" name="TextBox 4"/>
           <p:cNvSpPr txBox="1"/>
           <p:nvPr/>
         </p:nvSpPr>
@@ -3649,7 +3659,7 @@
               </a:defRPr>
             </a:pPr>
             <a:r>
-              <a:t>Conclusions</a:t>
+              <a:t>Failure cases and limitations</a:t>
             </a:r>
           </a:p>
         </p:txBody>
@@ -3687,7 +3697,7 @@
               </a:defRPr>
             </a:pPr>
             <a:r>
-              <a:t>CORES transfers effectively from classification to dense depth estimation.</a:t>
+              <a:t>NYU indoor versus KITTI roads is a broad, visually easy domain shift.</a:t>
             </a:r>
           </a:p>
           <a:p>
@@ -3702,7 +3712,7 @@
               </a:defRPr>
             </a:pPr>
             <a:r>
-              <a:t>The middle encoder magnitude is the simplest and strongest detector.</a:t>
+              <a:t>The NYU model is capped at 10 m, so KITTI metric depth deteriorates sharply.</a:t>
             </a:r>
           </a:p>
           <a:p>
@@ -3717,7 +3727,7 @@
               </a:defRPr>
             </a:pPr>
             <a:r>
-              <a:t>Weak late/decoder layers can dilute multi-layer aggregation.</a:t>
+              <a:t>Gaussian near-OOD corruption: AUROC 0.94273, FPR95 0.388.</a:t>
             </a:r>
           </a:p>
           <a:p>
@@ -3732,7 +3742,7 @@
               </a:defRPr>
             </a:pPr>
             <a:r>
-              <a:t>The result is stable, but naturally occurring near-OOD remains open.</a:t>
+              <a:t>One trained checkpoint per architecture; parameter count is not isolated.</a:t>
             </a:r>
           </a:p>
           <a:p>
@@ -3747,7 +3757,22 @@
               </a:defRPr>
             </a:pPr>
             <a:r>
-              <a:t>Repository contains notebook, checkpoints, raw tables, figures, tests and report.</a:t>
+              <a:t>FastDepth-style MobileNetV2, not an exact MobileNetV1 reproduction.</a:t>
+            </a:r>
+          </a:p>
+          <a:p>
+            <a:pPr>
+              <a:spcAft>
+                <a:spcPts val="1400"/>
+              </a:spcAft>
+              <a:defRPr sz="2000">
+                <a:solidFill>
+                  <a:srgbClr val="232323"/>
+                </a:solidFill>
+              </a:defRPr>
+            </a:pPr>
+            <a:r>
+              <a:t>Dense-prediction channel selection is an explicit adaptation of CORES.</a:t>
             </a:r>
           </a:p>
         </p:txBody>
@@ -3783,6 +3808,215 @@
             </a:pPr>
             <a:r>
               <a:t>12</a:t>
+            </a:r>
+          </a:p>
+        </p:txBody>
+      </p:sp>
+    </p:spTree>
+  </p:cSld>
+  <p:clrMapOvr>
+    <a:masterClrMapping/>
+  </p:clrMapOvr>
+</p:sld>
+</file>
+
+<file path=ppt/slides/slide13.xml><?xml version="1.0" encoding="utf-8"?>
+<p:sld xmlns:a="http://schemas.openxmlformats.org/drawingml/2006/main" xmlns:p="http://schemas.openxmlformats.org/presentationml/2006/main" xmlns:r="http://schemas.openxmlformats.org/officeDocument/2006/relationships">
+  <p:cSld>
+    <p:bg>
+      <p:bgPr>
+        <a:solidFill>
+          <a:srgbClr val="F5F7FA"/>
+        </a:solidFill>
+        <a:effectLst/>
+      </p:bgPr>
+    </p:bg>
+    <p:spTree>
+      <p:nvGrpSpPr>
+        <p:cNvPr id="1" name=""/>
+        <p:cNvGrpSpPr/>
+        <p:nvPr/>
+      </p:nvGrpSpPr>
+      <p:grpSpPr/>
+      <p:sp>
+        <p:nvSpPr>
+          <p:cNvPr id="2" name="TextBox 1"/>
+          <p:cNvSpPr txBox="1"/>
+          <p:nvPr/>
+        </p:nvSpPr>
+        <p:spPr>
+          <a:xfrm>
+            <a:off x="594360" y="320040"/>
+            <a:ext cx="10972800" cy="594360"/>
+          </a:xfrm>
+          <a:prstGeom prst="rect">
+            <a:avLst/>
+          </a:prstGeom>
+          <a:noFill/>
+        </p:spPr>
+        <p:txBody>
+          <a:bodyPr wrap="none">
+            <a:spAutoFit/>
+          </a:bodyPr>
+          <a:lstStyle/>
+          <a:p>
+            <a:pPr>
+              <a:defRPr sz="2800" b="1">
+                <a:solidFill>
+                  <a:srgbClr val="182D4E"/>
+                </a:solidFill>
+              </a:defRPr>
+            </a:pPr>
+            <a:r>
+              <a:t>Conclusions</a:t>
+            </a:r>
+          </a:p>
+        </p:txBody>
+      </p:sp>
+      <p:sp>
+        <p:nvSpPr>
+          <p:cNvPr id="3" name="TextBox 2"/>
+          <p:cNvSpPr txBox="1"/>
+          <p:nvPr/>
+        </p:nvSpPr>
+        <p:spPr>
+          <a:xfrm>
+            <a:off x="731520" y="1234440"/>
+            <a:ext cx="10515600" cy="5029200"/>
+          </a:xfrm>
+          <a:prstGeom prst="rect">
+            <a:avLst/>
+          </a:prstGeom>
+          <a:noFill/>
+        </p:spPr>
+        <p:txBody>
+          <a:bodyPr wrap="square">
+            <a:spAutoFit/>
+          </a:bodyPr>
+          <a:lstStyle/>
+          <a:p>
+            <a:pPr>
+              <a:spcAft>
+                <a:spcPts val="1400"/>
+              </a:spcAft>
+              <a:defRPr sz="2000">
+                <a:solidFill>
+                  <a:srgbClr val="232323"/>
+                </a:solidFill>
+              </a:defRPr>
+            </a:pPr>
+            <a:r>
+              <a:t>CORES transfers effectively from classification to dense depth estimation.</a:t>
+            </a:r>
+          </a:p>
+          <a:p>
+            <a:pPr>
+              <a:spcAft>
+                <a:spcPts val="1400"/>
+              </a:spcAft>
+              <a:defRPr sz="2000">
+                <a:solidFill>
+                  <a:srgbClr val="232323"/>
+                </a:solidFill>
+              </a:defRPr>
+            </a:pPr>
+            <a:r>
+              <a:t>The middle encoder magnitude is the simplest and strongest detector.</a:t>
+            </a:r>
+          </a:p>
+          <a:p>
+            <a:pPr>
+              <a:spcAft>
+                <a:spcPts val="1400"/>
+              </a:spcAft>
+              <a:defRPr sz="2000">
+                <a:solidFill>
+                  <a:srgbClr val="232323"/>
+                </a:solidFill>
+              </a:defRPr>
+            </a:pPr>
+            <a:r>
+              <a:t>Weak late/decoder layers can dilute multi-layer aggregation.</a:t>
+            </a:r>
+          </a:p>
+          <a:p>
+            <a:pPr>
+              <a:spcAft>
+                <a:spcPts val="1400"/>
+              </a:spcAft>
+              <a:defRPr sz="2000">
+                <a:solidFill>
+                  <a:srgbClr val="232323"/>
+                </a:solidFill>
+              </a:defRPr>
+            </a:pPr>
+            <a:r>
+              <a:t>The result is stable, but naturally occurring near-OOD remains open.</a:t>
+            </a:r>
+          </a:p>
+          <a:p>
+            <a:pPr>
+              <a:spcAft>
+                <a:spcPts val="1400"/>
+              </a:spcAft>
+              <a:defRPr sz="2000">
+                <a:solidFill>
+                  <a:srgbClr val="232323"/>
+                </a:solidFill>
+              </a:defRPr>
+            </a:pPr>
+            <a:r>
+              <a:t>ResNet18 confirms that near-perfect CORES separation is not universal.</a:t>
+            </a:r>
+          </a:p>
+          <a:p>
+            <a:pPr>
+              <a:spcAft>
+                <a:spcPts val="1400"/>
+              </a:spcAft>
+              <a:defRPr sz="2000">
+                <a:solidFill>
+                  <a:srgbClr val="232323"/>
+                </a:solidFill>
+              </a:defRPr>
+            </a:pPr>
+            <a:r>
+              <a:t>Repository contains notebook, checkpoints, raw tables, figures, tests and report.</a:t>
+            </a:r>
+          </a:p>
+        </p:txBody>
+      </p:sp>
+      <p:sp>
+        <p:nvSpPr>
+          <p:cNvPr id="4" name="TextBox 3"/>
+          <p:cNvSpPr txBox="1"/>
+          <p:nvPr/>
+        </p:nvSpPr>
+        <p:spPr>
+          <a:xfrm>
+            <a:off x="10789920" y="6446520"/>
+            <a:ext cx="731520" cy="228600"/>
+          </a:xfrm>
+          <a:prstGeom prst="rect">
+            <a:avLst/>
+          </a:prstGeom>
+          <a:noFill/>
+        </p:spPr>
+        <p:txBody>
+          <a:bodyPr wrap="none">
+            <a:spAutoFit/>
+          </a:bodyPr>
+          <a:lstStyle/>
+          <a:p>
+            <a:pPr algn="r">
+              <a:defRPr sz="1000">
+                <a:solidFill>
+                  <a:srgbClr val="787878"/>
+                </a:solidFill>
+              </a:defRPr>
+            </a:pPr>
+            <a:r>
+              <a:t>13</a:t>
             </a:r>
           </a:p>
         </p:txBody>

</xml_diff>